<commit_message>
- complete list of countries - auto-complete list box for countries - Provinces for some countries added - auto select country for a dataset and filter privinces for selected country
</commit_message>
<xml_diff>
--- a/AlamutB/.appCatalog/_demo for Alamut - LinkedIn.pptx
+++ b/AlamutB/.appCatalog/_demo for Alamut - LinkedIn.pptx
@@ -21,6 +21,10 @@
     <p:sldId id="269" r:id="rId15"/>
     <p:sldId id="270" r:id="rId16"/>
     <p:sldId id="271" r:id="rId17"/>
+    <p:sldId id="273" r:id="rId18"/>
+    <p:sldId id="274" r:id="rId19"/>
+    <p:sldId id="275" r:id="rId20"/>
+    <p:sldId id="276" r:id="rId21"/>
   </p:sldIdLst>
   <p:sldSz cx="12192000" cy="6858000"/>
   <p:notesSz cx="6858000" cy="9144000"/>
@@ -372,7 +376,7 @@
           <a:p>
             <a:fld id="{63E7CB08-B19C-4C97-A58E-0244DC130B9B}" type="datetimeFigureOut">
               <a:rPr lang="en-US" smtClean="0"/>
-              <a:t>9/6/2026</a:t>
+              <a:t>9/9/2026</a:t>
             </a:fld>
             <a:endParaRPr lang="en-US"/>
           </a:p>
@@ -634,7 +638,7 @@
           <a:p>
             <a:fld id="{63E7CB08-B19C-4C97-A58E-0244DC130B9B}" type="datetimeFigureOut">
               <a:rPr lang="en-US" smtClean="0"/>
-              <a:t>9/6/2026</a:t>
+              <a:t>9/9/2026</a:t>
             </a:fld>
             <a:endParaRPr lang="en-US"/>
           </a:p>
@@ -869,7 +873,7 @@
           <a:p>
             <a:fld id="{63E7CB08-B19C-4C97-A58E-0244DC130B9B}" type="datetimeFigureOut">
               <a:rPr lang="en-US" smtClean="0"/>
-              <a:t>9/6/2026</a:t>
+              <a:t>9/9/2026</a:t>
             </a:fld>
             <a:endParaRPr lang="en-US"/>
           </a:p>
@@ -1109,7 +1113,7 @@
           <a:p>
             <a:fld id="{63E7CB08-B19C-4C97-A58E-0244DC130B9B}" type="datetimeFigureOut">
               <a:rPr lang="en-US" smtClean="0"/>
-              <a:t>9/6/2026</a:t>
+              <a:t>9/9/2026</a:t>
             </a:fld>
             <a:endParaRPr lang="en-US"/>
           </a:p>
@@ -1416,7 +1420,7 @@
           <a:p>
             <a:fld id="{63E7CB08-B19C-4C97-A58E-0244DC130B9B}" type="datetimeFigureOut">
               <a:rPr lang="en-US" smtClean="0"/>
-              <a:t>9/6/2026</a:t>
+              <a:t>9/9/2026</a:t>
             </a:fld>
             <a:endParaRPr lang="en-US"/>
           </a:p>
@@ -1718,7 +1722,7 @@
           <a:p>
             <a:fld id="{63E7CB08-B19C-4C97-A58E-0244DC130B9B}" type="datetimeFigureOut">
               <a:rPr lang="en-US" smtClean="0"/>
-              <a:t>9/6/2026</a:t>
+              <a:t>9/9/2026</a:t>
             </a:fld>
             <a:endParaRPr lang="en-US"/>
           </a:p>
@@ -2140,7 +2144,7 @@
           <a:p>
             <a:fld id="{63E7CB08-B19C-4C97-A58E-0244DC130B9B}" type="datetimeFigureOut">
               <a:rPr lang="en-US" smtClean="0"/>
-              <a:t>9/6/2026</a:t>
+              <a:t>9/9/2026</a:t>
             </a:fld>
             <a:endParaRPr lang="en-US"/>
           </a:p>
@@ -2302,7 +2306,7 @@
           <a:p>
             <a:fld id="{63E7CB08-B19C-4C97-A58E-0244DC130B9B}" type="datetimeFigureOut">
               <a:rPr lang="en-US" smtClean="0"/>
-              <a:t>9/6/2026</a:t>
+              <a:t>9/9/2026</a:t>
             </a:fld>
             <a:endParaRPr lang="en-US"/>
           </a:p>
@@ -2397,7 +2401,7 @@
           <a:p>
             <a:fld id="{63E7CB08-B19C-4C97-A58E-0244DC130B9B}" type="datetimeFigureOut">
               <a:rPr lang="en-US" smtClean="0"/>
-              <a:t>9/6/2026</a:t>
+              <a:t>9/9/2026</a:t>
             </a:fld>
             <a:endParaRPr lang="en-US"/>
           </a:p>
@@ -2775,7 +2779,7 @@
           <a:p>
             <a:fld id="{63E7CB08-B19C-4C97-A58E-0244DC130B9B}" type="datetimeFigureOut">
               <a:rPr lang="en-US" smtClean="0"/>
-              <a:t>9/6/2026</a:t>
+              <a:t>9/9/2026</a:t>
             </a:fld>
             <a:endParaRPr lang="en-US"/>
           </a:p>
@@ -3064,7 +3068,7 @@
           <a:p>
             <a:fld id="{63E7CB08-B19C-4C97-A58E-0244DC130B9B}" type="datetimeFigureOut">
               <a:rPr lang="en-US" smtClean="0"/>
-              <a:t>9/6/2026</a:t>
+              <a:t>9/9/2026</a:t>
             </a:fld>
             <a:endParaRPr lang="en-US"/>
           </a:p>
@@ -3275,7 +3279,7 @@
           <a:p>
             <a:fld id="{63E7CB08-B19C-4C97-A58E-0244DC130B9B}" type="datetimeFigureOut">
               <a:rPr lang="en-US" smtClean="0"/>
-              <a:t>9/6/2026</a:t>
+              <a:t>9/9/2026</a:t>
             </a:fld>
             <a:endParaRPr lang="en-US"/>
           </a:p>
@@ -8567,7 +8571,7 @@
               <a:rPr lang="en-US" sz="6000">
                 <a:latin typeface="Barlow Condensed ExtraLight" panose="00000306000000000000" pitchFamily="2" charset="0"/>
               </a:rPr>
-              <a:t>Clculate FV of a region</a:t>
+              <a:t>Calculate FV of a region</a:t>
             </a:r>
           </a:p>
           <a:p>
@@ -8634,6 +8638,543 @@
     <p:extLst>
       <p:ext uri="{BB962C8B-B14F-4D97-AF65-F5344CB8AC3E}">
         <p14:creationId xmlns:p14="http://schemas.microsoft.com/office/powerpoint/2010/main" val="2219995869"/>
+      </p:ext>
+    </p:extLst>
+  </p:cSld>
+  <p:clrMapOvr>
+    <a:masterClrMapping/>
+  </p:clrMapOvr>
+</p:sld>
+</file>
+
+<file path=ppt/slides/slide17.xml><?xml version="1.0" encoding="utf-8"?>
+<p:sld xmlns:a="http://schemas.openxmlformats.org/drawingml/2006/main" xmlns:r="http://schemas.openxmlformats.org/officeDocument/2006/relationships" xmlns:p="http://schemas.openxmlformats.org/presentationml/2006/main">
+  <p:cSld>
+    <p:spTree>
+      <p:nvGrpSpPr>
+        <p:cNvPr id="1" name="">
+          <a:extLst>
+            <a:ext uri="{FF2B5EF4-FFF2-40B4-BE49-F238E27FC236}">
+              <a16:creationId xmlns:a16="http://schemas.microsoft.com/office/drawing/2014/main" id="{D0386B03-CC86-31D7-5D27-0475101D177C}"/>
+            </a:ext>
+          </a:extLst>
+        </p:cNvPr>
+        <p:cNvGrpSpPr/>
+        <p:nvPr/>
+      </p:nvGrpSpPr>
+      <p:grpSpPr>
+        <a:xfrm>
+          <a:off x="0" y="0"/>
+          <a:ext cx="0" cy="0"/>
+          <a:chOff x="0" y="0"/>
+          <a:chExt cx="0" cy="0"/>
+        </a:xfrm>
+      </p:grpSpPr>
+      <p:grpSp>
+        <p:nvGrpSpPr>
+          <p:cNvPr id="2" name="Group 1">
+            <a:extLst>
+              <a:ext uri="{FF2B5EF4-FFF2-40B4-BE49-F238E27FC236}">
+                <a16:creationId xmlns:a16="http://schemas.microsoft.com/office/drawing/2014/main" id="{B7137BE6-3BF1-0D99-5DAD-5D85886CD88A}"/>
+              </a:ext>
+            </a:extLst>
+          </p:cNvPr>
+          <p:cNvGrpSpPr/>
+          <p:nvPr/>
+        </p:nvGrpSpPr>
+        <p:grpSpPr>
+          <a:xfrm>
+            <a:off x="1492265" y="684300"/>
+            <a:ext cx="9197163" cy="3197227"/>
+            <a:chOff x="0" y="368960"/>
+            <a:chExt cx="10572223" cy="5038746"/>
+          </a:xfrm>
+        </p:grpSpPr>
+        <p:sp>
+          <p:nvSpPr>
+            <p:cNvPr id="6" name="Isosceles Triangle 5">
+              <a:extLst>
+                <a:ext uri="{FF2B5EF4-FFF2-40B4-BE49-F238E27FC236}">
+                  <a16:creationId xmlns:a16="http://schemas.microsoft.com/office/drawing/2014/main" id="{16501AAE-A4DB-74D7-8391-EE8BA1EACB30}"/>
+                </a:ext>
+              </a:extLst>
+            </p:cNvPr>
+            <p:cNvSpPr/>
+            <p:nvPr/>
+          </p:nvSpPr>
+          <p:spPr>
+            <a:xfrm>
+              <a:off x="0" y="939103"/>
+              <a:ext cx="10572223" cy="4468603"/>
+            </a:xfrm>
+            <a:custGeom>
+              <a:avLst/>
+              <a:gdLst>
+                <a:gd name="csX0" fmla="*/ 0 w 8324850"/>
+                <a:gd name="csY0" fmla="*/ 4282379 h 4282379"/>
+                <a:gd name="csX1" fmla="*/ 7010400 w 8324850"/>
+                <a:gd name="csY1" fmla="*/ 0 h 4282379"/>
+                <a:gd name="csX2" fmla="*/ 8324850 w 8324850"/>
+                <a:gd name="csY2" fmla="*/ 4282379 h 4282379"/>
+                <a:gd name="csX3" fmla="*/ 0 w 8324850"/>
+                <a:gd name="csY3" fmla="*/ 4282379 h 4282379"/>
+              </a:gdLst>
+              <a:ahLst/>
+              <a:cxnLst>
+                <a:cxn ang="0">
+                  <a:pos x="csX0" y="csY0"/>
+                </a:cxn>
+                <a:cxn ang="0">
+                  <a:pos x="csX1" y="csY1"/>
+                </a:cxn>
+                <a:cxn ang="0">
+                  <a:pos x="csX2" y="csY2"/>
+                </a:cxn>
+                <a:cxn ang="0">
+                  <a:pos x="csX3" y="csY3"/>
+                </a:cxn>
+              </a:cxnLst>
+              <a:rect l="l" t="t" r="r" b="b"/>
+              <a:pathLst>
+                <a:path w="8324850" h="4282379">
+                  <a:moveTo>
+                    <a:pt x="0" y="4282379"/>
+                  </a:moveTo>
+                  <a:lnTo>
+                    <a:pt x="7010400" y="0"/>
+                  </a:lnTo>
+                  <a:lnTo>
+                    <a:pt x="8324850" y="4282379"/>
+                  </a:lnTo>
+                  <a:lnTo>
+                    <a:pt x="0" y="4282379"/>
+                  </a:lnTo>
+                  <a:close/>
+                </a:path>
+              </a:pathLst>
+            </a:custGeom>
+            <a:solidFill>
+              <a:srgbClr val="C4E59F"/>
+            </a:solidFill>
+            <a:ln>
+              <a:noFill/>
+            </a:ln>
+          </p:spPr>
+          <p:style>
+            <a:lnRef idx="2">
+              <a:schemeClr val="accent1">
+                <a:shade val="15000"/>
+              </a:schemeClr>
+            </a:lnRef>
+            <a:fillRef idx="1">
+              <a:schemeClr val="accent1"/>
+            </a:fillRef>
+            <a:effectRef idx="0">
+              <a:schemeClr val="accent1"/>
+            </a:effectRef>
+            <a:fontRef idx="minor">
+              <a:schemeClr val="lt1"/>
+            </a:fontRef>
+          </p:style>
+          <p:txBody>
+            <a:bodyPr rtlCol="0" anchor="ctr"/>
+            <a:lstStyle/>
+            <a:p>
+              <a:pPr algn="ctr"/>
+              <a:endParaRPr lang="en-US"/>
+            </a:p>
+          </p:txBody>
+        </p:sp>
+        <p:sp>
+          <p:nvSpPr>
+            <p:cNvPr id="5" name="TextBox 4">
+              <a:extLst>
+                <a:ext uri="{FF2B5EF4-FFF2-40B4-BE49-F238E27FC236}">
+                  <a16:creationId xmlns:a16="http://schemas.microsoft.com/office/drawing/2014/main" id="{0A4731FD-E60A-9E0B-2952-4B1280B22582}"/>
+                </a:ext>
+              </a:extLst>
+            </p:cNvPr>
+            <p:cNvSpPr txBox="1"/>
+            <p:nvPr/>
+          </p:nvSpPr>
+          <p:spPr>
+            <a:xfrm>
+              <a:off x="779497" y="368960"/>
+              <a:ext cx="6287554" cy="4171410"/>
+            </a:xfrm>
+            <a:prstGeom prst="rect">
+              <a:avLst/>
+            </a:prstGeom>
+            <a:noFill/>
+          </p:spPr>
+          <p:txBody>
+            <a:bodyPr wrap="square" rtlCol="0">
+              <a:spAutoFit/>
+            </a:bodyPr>
+            <a:lstStyle/>
+            <a:p>
+              <a:pPr algn="l" rtl="0"/>
+              <a:r>
+                <a:rPr lang="en-US" sz="16600" i="1">
+                  <a:solidFill>
+                    <a:schemeClr val="tx1"/>
+                  </a:solidFill>
+                  <a:latin typeface="Rastanty Cortez" panose="020F0502020204030204" pitchFamily="2" charset="0"/>
+                  <a:ea typeface="Dotum" panose="020B0600000101010101" pitchFamily="34" charset="-127"/>
+                  <a:cs typeface="Biome Light" panose="020B0303030204020804" pitchFamily="34" charset="0"/>
+                </a:rPr>
+                <a:t>Al</a:t>
+              </a:r>
+              <a:r>
+                <a:rPr lang="en-US" sz="16600" i="1">
+                  <a:latin typeface="Rastanty Cortez" panose="020F0502020204030204" pitchFamily="2" charset="0"/>
+                  <a:ea typeface="Dotum" panose="020B0600000101010101" pitchFamily="34" charset="-127"/>
+                  <a:cs typeface="Biome Light" panose="020B0303030204020804" pitchFamily="34" charset="0"/>
+                </a:rPr>
+                <a:t>a</a:t>
+              </a:r>
+              <a:r>
+                <a:rPr lang="en-US" sz="16600" i="1">
+                  <a:solidFill>
+                    <a:srgbClr val="C00000"/>
+                  </a:solidFill>
+                  <a:latin typeface="Rastanty Cortez" panose="020F0502020204030204" pitchFamily="2" charset="0"/>
+                  <a:ea typeface="Dotum" panose="020B0600000101010101" pitchFamily="34" charset="-127"/>
+                  <a:cs typeface="Biome Light" panose="020B0303030204020804" pitchFamily="34" charset="0"/>
+                </a:rPr>
+                <a:t>m</a:t>
+              </a:r>
+              <a:r>
+                <a:rPr lang="en-US" sz="16600" i="1">
+                  <a:solidFill>
+                    <a:schemeClr val="tx1"/>
+                  </a:solidFill>
+                  <a:latin typeface="Rastanty Cortez" panose="020F0502020204030204" pitchFamily="2" charset="0"/>
+                  <a:ea typeface="Dotum" panose="020B0600000101010101" pitchFamily="34" charset="-127"/>
+                  <a:cs typeface="Biome Light" panose="020B0303030204020804" pitchFamily="34" charset="0"/>
+                </a:rPr>
+                <a:t>ut</a:t>
+              </a:r>
+            </a:p>
+          </p:txBody>
+        </p:sp>
+      </p:grpSp>
+      <p:sp>
+        <p:nvSpPr>
+          <p:cNvPr id="3" name="TextBox 2">
+            <a:extLst>
+              <a:ext uri="{FF2B5EF4-FFF2-40B4-BE49-F238E27FC236}">
+                <a16:creationId xmlns:a16="http://schemas.microsoft.com/office/drawing/2014/main" id="{1589BF2A-E173-A5A7-E693-29CFD9344029}"/>
+              </a:ext>
+            </a:extLst>
+          </p:cNvPr>
+          <p:cNvSpPr txBox="1"/>
+          <p:nvPr/>
+        </p:nvSpPr>
+        <p:spPr>
+          <a:xfrm>
+            <a:off x="2050637" y="4297678"/>
+            <a:ext cx="8080417" cy="1200329"/>
+          </a:xfrm>
+          <a:prstGeom prst="rect">
+            <a:avLst/>
+          </a:prstGeom>
+          <a:noFill/>
+        </p:spPr>
+        <p:txBody>
+          <a:bodyPr wrap="none" rtlCol="0">
+            <a:spAutoFit/>
+          </a:bodyPr>
+          <a:lstStyle/>
+          <a:p>
+            <a:r>
+              <a:rPr lang="en-US" sz="7200">
+                <a:solidFill>
+                  <a:schemeClr val="accent4">
+                    <a:lumMod val="75000"/>
+                  </a:schemeClr>
+                </a:solidFill>
+                <a:latin typeface="Perpetua Titling MT" panose="02020502060505020804" pitchFamily="18" charset="0"/>
+              </a:rPr>
+              <a:t>Create </a:t>
+            </a:r>
+            <a:r>
+              <a:rPr lang="en-US" sz="4400">
+                <a:solidFill>
+                  <a:schemeClr val="accent4">
+                    <a:lumMod val="75000"/>
+                  </a:schemeClr>
+                </a:solidFill>
+                <a:latin typeface="Perpetua Titling MT" panose="02020502060505020804" pitchFamily="18" charset="0"/>
+              </a:rPr>
+              <a:t>new Datasets</a:t>
+            </a:r>
+            <a:endParaRPr lang="en-US" sz="7200">
+              <a:solidFill>
+                <a:schemeClr val="accent4">
+                  <a:lumMod val="75000"/>
+                </a:schemeClr>
+              </a:solidFill>
+              <a:latin typeface="Perpetua Titling MT" panose="02020502060505020804" pitchFamily="18" charset="0"/>
+            </a:endParaRPr>
+          </a:p>
+        </p:txBody>
+      </p:sp>
+      <p:sp>
+        <p:nvSpPr>
+          <p:cNvPr id="7" name="TextBox 6">
+            <a:extLst>
+              <a:ext uri="{FF2B5EF4-FFF2-40B4-BE49-F238E27FC236}">
+                <a16:creationId xmlns:a16="http://schemas.microsoft.com/office/drawing/2014/main" id="{CB769659-9376-AD82-94EC-4783511E5F54}"/>
+              </a:ext>
+            </a:extLst>
+          </p:cNvPr>
+          <p:cNvSpPr txBox="1"/>
+          <p:nvPr/>
+        </p:nvSpPr>
+        <p:spPr>
+          <a:xfrm>
+            <a:off x="2821393" y="5914158"/>
+            <a:ext cx="6371937" cy="707886"/>
+          </a:xfrm>
+          <a:prstGeom prst="rect">
+            <a:avLst/>
+          </a:prstGeom>
+          <a:noFill/>
+        </p:spPr>
+        <p:txBody>
+          <a:bodyPr wrap="none" rtlCol="0">
+            <a:spAutoFit/>
+          </a:bodyPr>
+          <a:lstStyle/>
+          <a:p>
+            <a:r>
+              <a:rPr lang="en-US" sz="4000">
+                <a:solidFill>
+                  <a:schemeClr val="accent5"/>
+                </a:solidFill>
+                <a:latin typeface="Perpetua Titling MT" panose="02020502060505020804" pitchFamily="18" charset="0"/>
+              </a:rPr>
+              <a:t>from published papers</a:t>
+            </a:r>
+          </a:p>
+        </p:txBody>
+      </p:sp>
+    </p:spTree>
+    <p:extLst>
+      <p:ext uri="{BB962C8B-B14F-4D97-AF65-F5344CB8AC3E}">
+        <p14:creationId xmlns:p14="http://schemas.microsoft.com/office/powerpoint/2010/main" val="1969012672"/>
+      </p:ext>
+    </p:extLst>
+  </p:cSld>
+  <p:clrMapOvr>
+    <a:masterClrMapping/>
+  </p:clrMapOvr>
+</p:sld>
+</file>
+
+<file path=ppt/slides/slide18.xml><?xml version="1.0" encoding="utf-8"?>
+<p:sld xmlns:a="http://schemas.openxmlformats.org/drawingml/2006/main" xmlns:r="http://schemas.openxmlformats.org/officeDocument/2006/relationships" xmlns:p="http://schemas.openxmlformats.org/presentationml/2006/main">
+  <p:cSld>
+    <p:spTree>
+      <p:nvGrpSpPr>
+        <p:cNvPr id="1" name="">
+          <a:extLst>
+            <a:ext uri="{FF2B5EF4-FFF2-40B4-BE49-F238E27FC236}">
+              <a16:creationId xmlns:a16="http://schemas.microsoft.com/office/drawing/2014/main" id="{7B946462-FDA5-6A83-0C7F-5FE321CC7070}"/>
+            </a:ext>
+          </a:extLst>
+        </p:cNvPr>
+        <p:cNvGrpSpPr/>
+        <p:nvPr/>
+      </p:nvGrpSpPr>
+      <p:grpSpPr>
+        <a:xfrm>
+          <a:off x="0" y="0"/>
+          <a:ext cx="0" cy="0"/>
+          <a:chOff x="0" y="0"/>
+          <a:chExt cx="0" cy="0"/>
+        </a:xfrm>
+      </p:grpSpPr>
+      <p:sp>
+        <p:nvSpPr>
+          <p:cNvPr id="3" name="TextBox 2">
+            <a:extLst>
+              <a:ext uri="{FF2B5EF4-FFF2-40B4-BE49-F238E27FC236}">
+                <a16:creationId xmlns:a16="http://schemas.microsoft.com/office/drawing/2014/main" id="{AFD6D842-9F56-56BF-D7CF-C1468DE042DC}"/>
+              </a:ext>
+            </a:extLst>
+          </p:cNvPr>
+          <p:cNvSpPr txBox="1"/>
+          <p:nvPr/>
+        </p:nvSpPr>
+        <p:spPr>
+          <a:xfrm>
+            <a:off x="452413" y="634015"/>
+            <a:ext cx="11335396" cy="1938992"/>
+          </a:xfrm>
+          <a:prstGeom prst="rect">
+            <a:avLst/>
+          </a:prstGeom>
+          <a:noFill/>
+        </p:spPr>
+        <p:txBody>
+          <a:bodyPr wrap="square" rtlCol="0">
+            <a:spAutoFit/>
+          </a:bodyPr>
+          <a:lstStyle/>
+          <a:p>
+            <a:pPr algn="l"/>
+            <a:r>
+              <a:rPr lang="en-US" sz="6000" b="1">
+                <a:latin typeface="Barlow Condensed ExtraLight" panose="00000306000000000000" pitchFamily="2" charset="0"/>
+              </a:rPr>
+              <a:t>Example: </a:t>
+            </a:r>
+            <a:r>
+              <a:rPr lang="en-US" sz="6000">
+                <a:latin typeface="Barlow Condensed ExtraLight" panose="00000306000000000000" pitchFamily="2" charset="0"/>
+              </a:rPr>
+              <a:t>List of Plant Species in tropical deciduous forests of Eastern Ghats, </a:t>
+            </a:r>
+            <a:r>
+              <a:rPr lang="en-US" sz="6000" b="1">
+                <a:solidFill>
+                  <a:schemeClr val="bg2">
+                    <a:lumMod val="75000"/>
+                  </a:schemeClr>
+                </a:solidFill>
+                <a:latin typeface="Barlow Condensed ExtraLight" panose="00000306000000000000" pitchFamily="2" charset="0"/>
+              </a:rPr>
+              <a:t>India</a:t>
+            </a:r>
+          </a:p>
+        </p:txBody>
+      </p:sp>
+      <p:pic>
+        <p:nvPicPr>
+          <p:cNvPr id="4" name="Picture 3">
+            <a:extLst>
+              <a:ext uri="{FF2B5EF4-FFF2-40B4-BE49-F238E27FC236}">
+                <a16:creationId xmlns:a16="http://schemas.microsoft.com/office/drawing/2014/main" id="{7C67AEF3-F967-89EF-5BF4-9DC20541D616}"/>
+              </a:ext>
+            </a:extLst>
+          </p:cNvPr>
+          <p:cNvPicPr>
+            <a:picLocks noChangeAspect="1"/>
+          </p:cNvPicPr>
+          <p:nvPr/>
+        </p:nvPicPr>
+        <p:blipFill>
+          <a:blip r:embed="rId2"/>
+          <a:stretch>
+            <a:fillRect/>
+          </a:stretch>
+        </p:blipFill>
+        <p:spPr>
+          <a:xfrm>
+            <a:off x="4564373" y="2573007"/>
+            <a:ext cx="7043968" cy="4017523"/>
+          </a:xfrm>
+          <a:prstGeom prst="rect">
+            <a:avLst/>
+          </a:prstGeom>
+        </p:spPr>
+      </p:pic>
+      <p:pic>
+        <p:nvPicPr>
+          <p:cNvPr id="6" name="Picture 5">
+            <a:extLst>
+              <a:ext uri="{FF2B5EF4-FFF2-40B4-BE49-F238E27FC236}">
+                <a16:creationId xmlns:a16="http://schemas.microsoft.com/office/drawing/2014/main" id="{6D9812B6-2228-EC64-AE41-603AE057A3BB}"/>
+              </a:ext>
+            </a:extLst>
+          </p:cNvPr>
+          <p:cNvPicPr>
+            <a:picLocks noChangeAspect="1"/>
+          </p:cNvPicPr>
+          <p:nvPr/>
+        </p:nvPicPr>
+        <p:blipFill>
+          <a:blip r:embed="rId3"/>
+          <a:stretch>
+            <a:fillRect/>
+          </a:stretch>
+        </p:blipFill>
+        <p:spPr>
+          <a:xfrm>
+            <a:off x="944227" y="2573007"/>
+            <a:ext cx="3083024" cy="4285349"/>
+          </a:xfrm>
+          <a:prstGeom prst="rect">
+            <a:avLst/>
+          </a:prstGeom>
+        </p:spPr>
+      </p:pic>
+    </p:spTree>
+    <p:extLst>
+      <p:ext uri="{BB962C8B-B14F-4D97-AF65-F5344CB8AC3E}">
+        <p14:creationId xmlns:p14="http://schemas.microsoft.com/office/powerpoint/2010/main" val="2372973292"/>
+      </p:ext>
+    </p:extLst>
+  </p:cSld>
+  <p:clrMapOvr>
+    <a:masterClrMapping/>
+  </p:clrMapOvr>
+</p:sld>
+</file>
+
+<file path=ppt/slides/slide19.xml><?xml version="1.0" encoding="utf-8"?>
+<p:sld xmlns:a="http://schemas.openxmlformats.org/drawingml/2006/main" xmlns:r="http://schemas.openxmlformats.org/officeDocument/2006/relationships" xmlns:p="http://schemas.openxmlformats.org/presentationml/2006/main">
+  <p:cSld>
+    <p:spTree>
+      <p:nvGrpSpPr>
+        <p:cNvPr id="1" name=""/>
+        <p:cNvGrpSpPr/>
+        <p:nvPr/>
+      </p:nvGrpSpPr>
+      <p:grpSpPr>
+        <a:xfrm>
+          <a:off x="0" y="0"/>
+          <a:ext cx="0" cy="0"/>
+          <a:chOff x="0" y="0"/>
+          <a:chExt cx="0" cy="0"/>
+        </a:xfrm>
+      </p:grpSpPr>
+      <p:pic>
+        <p:nvPicPr>
+          <p:cNvPr id="3" name="Picture 2">
+            <a:extLst>
+              <a:ext uri="{FF2B5EF4-FFF2-40B4-BE49-F238E27FC236}">
+                <a16:creationId xmlns:a16="http://schemas.microsoft.com/office/drawing/2014/main" id="{0197D26D-DC87-BFE9-7AB3-954A7D89B20C}"/>
+              </a:ext>
+            </a:extLst>
+          </p:cNvPr>
+          <p:cNvPicPr>
+            <a:picLocks noChangeAspect="1"/>
+          </p:cNvPicPr>
+          <p:nvPr/>
+        </p:nvPicPr>
+        <p:blipFill>
+          <a:blip r:embed="rId2"/>
+          <a:stretch>
+            <a:fillRect/>
+          </a:stretch>
+        </p:blipFill>
+        <p:spPr>
+          <a:xfrm>
+            <a:off x="1109660" y="564553"/>
+            <a:ext cx="9972680" cy="6312903"/>
+          </a:xfrm>
+          <a:prstGeom prst="rect">
+            <a:avLst/>
+          </a:prstGeom>
+        </p:spPr>
+      </p:pic>
+    </p:spTree>
+    <p:extLst>
+      <p:ext uri="{BB962C8B-B14F-4D97-AF65-F5344CB8AC3E}">
+        <p14:creationId xmlns:p14="http://schemas.microsoft.com/office/powerpoint/2010/main" val="3288077734"/>
       </p:ext>
     </p:extLst>
   </p:cSld>
@@ -8812,6 +9353,127 @@
   </p:cSld>
   <p:clrMapOvr>
     <a:overrideClrMapping bg1="lt1" tx1="dk1" bg2="lt2" tx2="dk2" accent1="accent1" accent2="accent2" accent3="accent3" accent4="accent4" accent5="accent5" accent6="accent6" hlink="hlink" folHlink="folHlink"/>
+  </p:clrMapOvr>
+</p:sld>
+</file>
+
+<file path=ppt/slides/slide20.xml><?xml version="1.0" encoding="utf-8"?>
+<p:sld xmlns:a="http://schemas.openxmlformats.org/drawingml/2006/main" xmlns:r="http://schemas.openxmlformats.org/officeDocument/2006/relationships" xmlns:p="http://schemas.openxmlformats.org/presentationml/2006/main">
+  <p:cSld>
+    <p:spTree>
+      <p:nvGrpSpPr>
+        <p:cNvPr id="1" name=""/>
+        <p:cNvGrpSpPr/>
+        <p:nvPr/>
+      </p:nvGrpSpPr>
+      <p:grpSpPr>
+        <a:xfrm>
+          <a:off x="0" y="0"/>
+          <a:ext cx="0" cy="0"/>
+          <a:chOff x="0" y="0"/>
+          <a:chExt cx="0" cy="0"/>
+        </a:xfrm>
+      </p:grpSpPr>
+      <p:pic>
+        <p:nvPicPr>
+          <p:cNvPr id="3" name="Picture 2">
+            <a:extLst>
+              <a:ext uri="{FF2B5EF4-FFF2-40B4-BE49-F238E27FC236}">
+                <a16:creationId xmlns:a16="http://schemas.microsoft.com/office/drawing/2014/main" id="{43B2245F-65C2-3A73-763C-973FEB001C95}"/>
+              </a:ext>
+            </a:extLst>
+          </p:cNvPr>
+          <p:cNvPicPr>
+            <a:picLocks noChangeAspect="1"/>
+          </p:cNvPicPr>
+          <p:nvPr/>
+        </p:nvPicPr>
+        <p:blipFill>
+          <a:blip r:embed="rId2"/>
+          <a:stretch>
+            <a:fillRect/>
+          </a:stretch>
+        </p:blipFill>
+        <p:spPr>
+          <a:xfrm>
+            <a:off x="776238" y="0"/>
+            <a:ext cx="5736783" cy="6858000"/>
+          </a:xfrm>
+          <a:prstGeom prst="rect">
+            <a:avLst/>
+          </a:prstGeom>
+        </p:spPr>
+      </p:pic>
+      <p:sp>
+        <p:nvSpPr>
+          <p:cNvPr id="5" name="TextBox 4">
+            <a:extLst>
+              <a:ext uri="{FF2B5EF4-FFF2-40B4-BE49-F238E27FC236}">
+                <a16:creationId xmlns:a16="http://schemas.microsoft.com/office/drawing/2014/main" id="{191D253A-C172-5427-097A-2EEBD6670B1C}"/>
+              </a:ext>
+            </a:extLst>
+          </p:cNvPr>
+          <p:cNvSpPr txBox="1"/>
+          <p:nvPr/>
+        </p:nvSpPr>
+        <p:spPr>
+          <a:xfrm>
+            <a:off x="7422204" y="1110670"/>
+            <a:ext cx="4569886" cy="2862322"/>
+          </a:xfrm>
+          <a:prstGeom prst="rect">
+            <a:avLst/>
+          </a:prstGeom>
+          <a:noFill/>
+        </p:spPr>
+        <p:txBody>
+          <a:bodyPr wrap="square" rtlCol="0">
+            <a:spAutoFit/>
+          </a:bodyPr>
+          <a:lstStyle/>
+          <a:p>
+            <a:pPr algn="l"/>
+            <a:r>
+              <a:rPr lang="en-US" sz="6000">
+                <a:latin typeface="Barlow Condensed ExtraLight" panose="00000306000000000000" pitchFamily="2" charset="0"/>
+              </a:rPr>
+              <a:t>This is a small list of just </a:t>
+            </a:r>
+            <a:r>
+              <a:rPr lang="en-US" sz="6000">
+                <a:solidFill>
+                  <a:srgbClr val="C00000"/>
+                </a:solidFill>
+                <a:latin typeface="Barlow Condensed ExtraLight" panose="00000306000000000000" pitchFamily="2" charset="0"/>
+              </a:rPr>
+              <a:t>50</a:t>
+            </a:r>
+            <a:r>
+              <a:rPr lang="en-US" sz="6000">
+                <a:latin typeface="Barlow Condensed ExtraLight" panose="00000306000000000000" pitchFamily="2" charset="0"/>
+              </a:rPr>
+              <a:t> Plant species</a:t>
+            </a:r>
+            <a:endParaRPr lang="en-US" sz="6000" b="1">
+              <a:solidFill>
+                <a:schemeClr val="bg2">
+                  <a:lumMod val="75000"/>
+                </a:schemeClr>
+              </a:solidFill>
+              <a:latin typeface="Barlow Condensed ExtraLight" panose="00000306000000000000" pitchFamily="2" charset="0"/>
+            </a:endParaRPr>
+          </a:p>
+        </p:txBody>
+      </p:sp>
+    </p:spTree>
+    <p:extLst>
+      <p:ext uri="{BB962C8B-B14F-4D97-AF65-F5344CB8AC3E}">
+        <p14:creationId xmlns:p14="http://schemas.microsoft.com/office/powerpoint/2010/main" val="4003859558"/>
+      </p:ext>
+    </p:extLst>
+  </p:cSld>
+  <p:clrMapOvr>
+    <a:masterClrMapping/>
   </p:clrMapOvr>
 </p:sld>
 </file>

</xml_diff>

<commit_message>
-R-Script save to client for analysis
</commit_message>
<xml_diff>
--- a/AlamutB/.appCatalog/_demo for Alamut - LinkedIn.pptx
+++ b/AlamutB/.appCatalog/_demo for Alamut - LinkedIn.pptx
@@ -27,6 +27,10 @@
     <p:sldId id="274" r:id="rId21"/>
     <p:sldId id="275" r:id="rId22"/>
     <p:sldId id="276" r:id="rId23"/>
+    <p:sldId id="279" r:id="rId24"/>
+    <p:sldId id="280" r:id="rId25"/>
+    <p:sldId id="281" r:id="rId26"/>
+    <p:sldId id="282" r:id="rId27"/>
   </p:sldIdLst>
   <p:sldSz cx="12192000" cy="6858000"/>
   <p:notesSz cx="6858000" cy="9144000"/>
@@ -378,7 +382,7 @@
           <a:p>
             <a:fld id="{63E7CB08-B19C-4C97-A58E-0244DC130B9B}" type="datetimeFigureOut">
               <a:rPr lang="en-US" smtClean="0"/>
-              <a:t>9/11/2026</a:t>
+              <a:t>9/20/2026</a:t>
             </a:fld>
             <a:endParaRPr lang="en-US"/>
           </a:p>
@@ -640,7 +644,7 @@
           <a:p>
             <a:fld id="{63E7CB08-B19C-4C97-A58E-0244DC130B9B}" type="datetimeFigureOut">
               <a:rPr lang="en-US" smtClean="0"/>
-              <a:t>9/11/2026</a:t>
+              <a:t>9/20/2026</a:t>
             </a:fld>
             <a:endParaRPr lang="en-US"/>
           </a:p>
@@ -875,7 +879,7 @@
           <a:p>
             <a:fld id="{63E7CB08-B19C-4C97-A58E-0244DC130B9B}" type="datetimeFigureOut">
               <a:rPr lang="en-US" smtClean="0"/>
-              <a:t>9/11/2026</a:t>
+              <a:t>9/20/2026</a:t>
             </a:fld>
             <a:endParaRPr lang="en-US"/>
           </a:p>
@@ -1115,7 +1119,7 @@
           <a:p>
             <a:fld id="{63E7CB08-B19C-4C97-A58E-0244DC130B9B}" type="datetimeFigureOut">
               <a:rPr lang="en-US" smtClean="0"/>
-              <a:t>9/11/2026</a:t>
+              <a:t>9/20/2026</a:t>
             </a:fld>
             <a:endParaRPr lang="en-US"/>
           </a:p>
@@ -1422,7 +1426,7 @@
           <a:p>
             <a:fld id="{63E7CB08-B19C-4C97-A58E-0244DC130B9B}" type="datetimeFigureOut">
               <a:rPr lang="en-US" smtClean="0"/>
-              <a:t>9/11/2026</a:t>
+              <a:t>9/20/2026</a:t>
             </a:fld>
             <a:endParaRPr lang="en-US"/>
           </a:p>
@@ -1724,7 +1728,7 @@
           <a:p>
             <a:fld id="{63E7CB08-B19C-4C97-A58E-0244DC130B9B}" type="datetimeFigureOut">
               <a:rPr lang="en-US" smtClean="0"/>
-              <a:t>9/11/2026</a:t>
+              <a:t>9/20/2026</a:t>
             </a:fld>
             <a:endParaRPr lang="en-US"/>
           </a:p>
@@ -2146,7 +2150,7 @@
           <a:p>
             <a:fld id="{63E7CB08-B19C-4C97-A58E-0244DC130B9B}" type="datetimeFigureOut">
               <a:rPr lang="en-US" smtClean="0"/>
-              <a:t>9/11/2026</a:t>
+              <a:t>9/20/2026</a:t>
             </a:fld>
             <a:endParaRPr lang="en-US"/>
           </a:p>
@@ -2308,7 +2312,7 @@
           <a:p>
             <a:fld id="{63E7CB08-B19C-4C97-A58E-0244DC130B9B}" type="datetimeFigureOut">
               <a:rPr lang="en-US" smtClean="0"/>
-              <a:t>9/11/2026</a:t>
+              <a:t>9/20/2026</a:t>
             </a:fld>
             <a:endParaRPr lang="en-US"/>
           </a:p>
@@ -2403,7 +2407,7 @@
           <a:p>
             <a:fld id="{63E7CB08-B19C-4C97-A58E-0244DC130B9B}" type="datetimeFigureOut">
               <a:rPr lang="en-US" smtClean="0"/>
-              <a:t>9/11/2026</a:t>
+              <a:t>9/20/2026</a:t>
             </a:fld>
             <a:endParaRPr lang="en-US"/>
           </a:p>
@@ -2781,7 +2785,7 @@
           <a:p>
             <a:fld id="{63E7CB08-B19C-4C97-A58E-0244DC130B9B}" type="datetimeFigureOut">
               <a:rPr lang="en-US" smtClean="0"/>
-              <a:t>9/11/2026</a:t>
+              <a:t>9/20/2026</a:t>
             </a:fld>
             <a:endParaRPr lang="en-US"/>
           </a:p>
@@ -3070,7 +3074,7 @@
           <a:p>
             <a:fld id="{63E7CB08-B19C-4C97-A58E-0244DC130B9B}" type="datetimeFigureOut">
               <a:rPr lang="en-US" smtClean="0"/>
-              <a:t>9/11/2026</a:t>
+              <a:t>9/20/2026</a:t>
             </a:fld>
             <a:endParaRPr lang="en-US"/>
           </a:p>
@@ -3281,7 +3285,7 @@
           <a:p>
             <a:fld id="{63E7CB08-B19C-4C97-A58E-0244DC130B9B}" type="datetimeFigureOut">
               <a:rPr lang="en-US" smtClean="0"/>
-              <a:t>9/11/2026</a:t>
+              <a:t>9/20/2026</a:t>
             </a:fld>
             <a:endParaRPr lang="en-US"/>
           </a:p>
@@ -9926,6 +9930,1012 @@
 </p:sld>
 </file>
 
+<file path=ppt/slides/slide23.xml><?xml version="1.0" encoding="utf-8"?>
+<p:sld xmlns:a="http://schemas.openxmlformats.org/drawingml/2006/main" xmlns:r="http://schemas.openxmlformats.org/officeDocument/2006/relationships" xmlns:p="http://schemas.openxmlformats.org/presentationml/2006/main">
+  <p:cSld>
+    <p:spTree>
+      <p:nvGrpSpPr>
+        <p:cNvPr id="1" name="">
+          <a:extLst>
+            <a:ext uri="{FF2B5EF4-FFF2-40B4-BE49-F238E27FC236}">
+              <a16:creationId xmlns:a16="http://schemas.microsoft.com/office/drawing/2014/main" id="{9BDA4BC4-F0EA-133D-9BF9-E938EEDB8DAE}"/>
+            </a:ext>
+          </a:extLst>
+        </p:cNvPr>
+        <p:cNvGrpSpPr/>
+        <p:nvPr/>
+      </p:nvGrpSpPr>
+      <p:grpSpPr>
+        <a:xfrm>
+          <a:off x="0" y="0"/>
+          <a:ext cx="0" cy="0"/>
+          <a:chOff x="0" y="0"/>
+          <a:chExt cx="0" cy="0"/>
+        </a:xfrm>
+      </p:grpSpPr>
+      <p:grpSp>
+        <p:nvGrpSpPr>
+          <p:cNvPr id="2" name="Group 1">
+            <a:extLst>
+              <a:ext uri="{FF2B5EF4-FFF2-40B4-BE49-F238E27FC236}">
+                <a16:creationId xmlns:a16="http://schemas.microsoft.com/office/drawing/2014/main" id="{CF42D18B-421A-0331-74C0-908F2A735A42}"/>
+              </a:ext>
+            </a:extLst>
+          </p:cNvPr>
+          <p:cNvGrpSpPr/>
+          <p:nvPr/>
+        </p:nvGrpSpPr>
+        <p:grpSpPr>
+          <a:xfrm>
+            <a:off x="1492264" y="684300"/>
+            <a:ext cx="9197163" cy="3197227"/>
+            <a:chOff x="0" y="368960"/>
+            <a:chExt cx="10572223" cy="5038746"/>
+          </a:xfrm>
+        </p:grpSpPr>
+        <p:sp>
+          <p:nvSpPr>
+            <p:cNvPr id="6" name="Isosceles Triangle 5">
+              <a:extLst>
+                <a:ext uri="{FF2B5EF4-FFF2-40B4-BE49-F238E27FC236}">
+                  <a16:creationId xmlns:a16="http://schemas.microsoft.com/office/drawing/2014/main" id="{AC06C33F-3A5D-CBFF-AD5A-FEC1D1522F07}"/>
+                </a:ext>
+              </a:extLst>
+            </p:cNvPr>
+            <p:cNvSpPr/>
+            <p:nvPr/>
+          </p:nvSpPr>
+          <p:spPr>
+            <a:xfrm>
+              <a:off x="0" y="939103"/>
+              <a:ext cx="10572223" cy="4468603"/>
+            </a:xfrm>
+            <a:custGeom>
+              <a:avLst/>
+              <a:gdLst>
+                <a:gd name="csX0" fmla="*/ 0 w 8324850"/>
+                <a:gd name="csY0" fmla="*/ 4282379 h 4282379"/>
+                <a:gd name="csX1" fmla="*/ 7010400 w 8324850"/>
+                <a:gd name="csY1" fmla="*/ 0 h 4282379"/>
+                <a:gd name="csX2" fmla="*/ 8324850 w 8324850"/>
+                <a:gd name="csY2" fmla="*/ 4282379 h 4282379"/>
+                <a:gd name="csX3" fmla="*/ 0 w 8324850"/>
+                <a:gd name="csY3" fmla="*/ 4282379 h 4282379"/>
+              </a:gdLst>
+              <a:ahLst/>
+              <a:cxnLst>
+                <a:cxn ang="0">
+                  <a:pos x="csX0" y="csY0"/>
+                </a:cxn>
+                <a:cxn ang="0">
+                  <a:pos x="csX1" y="csY1"/>
+                </a:cxn>
+                <a:cxn ang="0">
+                  <a:pos x="csX2" y="csY2"/>
+                </a:cxn>
+                <a:cxn ang="0">
+                  <a:pos x="csX3" y="csY3"/>
+                </a:cxn>
+              </a:cxnLst>
+              <a:rect l="l" t="t" r="r" b="b"/>
+              <a:pathLst>
+                <a:path w="8324850" h="4282379">
+                  <a:moveTo>
+                    <a:pt x="0" y="4282379"/>
+                  </a:moveTo>
+                  <a:lnTo>
+                    <a:pt x="7010400" y="0"/>
+                  </a:lnTo>
+                  <a:lnTo>
+                    <a:pt x="8324850" y="4282379"/>
+                  </a:lnTo>
+                  <a:lnTo>
+                    <a:pt x="0" y="4282379"/>
+                  </a:lnTo>
+                  <a:close/>
+                </a:path>
+              </a:pathLst>
+            </a:custGeom>
+            <a:solidFill>
+              <a:srgbClr val="99CCFF"/>
+            </a:solidFill>
+            <a:ln>
+              <a:noFill/>
+            </a:ln>
+          </p:spPr>
+          <p:style>
+            <a:lnRef idx="2">
+              <a:schemeClr val="accent1">
+                <a:shade val="15000"/>
+              </a:schemeClr>
+            </a:lnRef>
+            <a:fillRef idx="1">
+              <a:schemeClr val="accent1"/>
+            </a:fillRef>
+            <a:effectRef idx="0">
+              <a:schemeClr val="accent1"/>
+            </a:effectRef>
+            <a:fontRef idx="minor">
+              <a:schemeClr val="lt1"/>
+            </a:fontRef>
+          </p:style>
+          <p:txBody>
+            <a:bodyPr rtlCol="0" anchor="ctr"/>
+            <a:lstStyle/>
+            <a:p>
+              <a:pPr algn="ctr"/>
+              <a:endParaRPr lang="en-US"/>
+            </a:p>
+          </p:txBody>
+        </p:sp>
+        <p:sp>
+          <p:nvSpPr>
+            <p:cNvPr id="5" name="TextBox 4">
+              <a:extLst>
+                <a:ext uri="{FF2B5EF4-FFF2-40B4-BE49-F238E27FC236}">
+                  <a16:creationId xmlns:a16="http://schemas.microsoft.com/office/drawing/2014/main" id="{D401CD4D-EC79-CDA6-FC2F-17AA5B1B4830}"/>
+                </a:ext>
+              </a:extLst>
+            </p:cNvPr>
+            <p:cNvSpPr txBox="1"/>
+            <p:nvPr/>
+          </p:nvSpPr>
+          <p:spPr>
+            <a:xfrm>
+              <a:off x="779497" y="368960"/>
+              <a:ext cx="6287554" cy="4171410"/>
+            </a:xfrm>
+            <a:prstGeom prst="rect">
+              <a:avLst/>
+            </a:prstGeom>
+            <a:noFill/>
+          </p:spPr>
+          <p:txBody>
+            <a:bodyPr wrap="square" rtlCol="0">
+              <a:spAutoFit/>
+            </a:bodyPr>
+            <a:lstStyle/>
+            <a:p>
+              <a:pPr algn="l" rtl="0"/>
+              <a:r>
+                <a:rPr lang="en-US" sz="16600" i="1">
+                  <a:solidFill>
+                    <a:schemeClr val="tx1"/>
+                  </a:solidFill>
+                  <a:latin typeface="Rastanty Cortez" panose="020F0502020204030204" pitchFamily="2" charset="0"/>
+                  <a:ea typeface="Dotum" panose="020B0600000101010101" pitchFamily="34" charset="-127"/>
+                  <a:cs typeface="Biome Light" panose="020B0303030204020804" pitchFamily="34" charset="0"/>
+                </a:rPr>
+                <a:t>Al</a:t>
+              </a:r>
+              <a:r>
+                <a:rPr lang="en-US" sz="16600" i="1">
+                  <a:latin typeface="Rastanty Cortez" panose="020F0502020204030204" pitchFamily="2" charset="0"/>
+                  <a:ea typeface="Dotum" panose="020B0600000101010101" pitchFamily="34" charset="-127"/>
+                  <a:cs typeface="Biome Light" panose="020B0303030204020804" pitchFamily="34" charset="0"/>
+                </a:rPr>
+                <a:t>a</a:t>
+              </a:r>
+              <a:r>
+                <a:rPr lang="en-US" sz="16600" i="1">
+                  <a:solidFill>
+                    <a:srgbClr val="C00000"/>
+                  </a:solidFill>
+                  <a:latin typeface="Rastanty Cortez" panose="020F0502020204030204" pitchFamily="2" charset="0"/>
+                  <a:ea typeface="Dotum" panose="020B0600000101010101" pitchFamily="34" charset="-127"/>
+                  <a:cs typeface="Biome Light" panose="020B0303030204020804" pitchFamily="34" charset="0"/>
+                </a:rPr>
+                <a:t>m</a:t>
+              </a:r>
+              <a:r>
+                <a:rPr lang="en-US" sz="16600" i="1">
+                  <a:solidFill>
+                    <a:schemeClr val="tx1"/>
+                  </a:solidFill>
+                  <a:latin typeface="Rastanty Cortez" panose="020F0502020204030204" pitchFamily="2" charset="0"/>
+                  <a:ea typeface="Dotum" panose="020B0600000101010101" pitchFamily="34" charset="-127"/>
+                  <a:cs typeface="Biome Light" panose="020B0303030204020804" pitchFamily="34" charset="0"/>
+                </a:rPr>
+                <a:t>ut</a:t>
+              </a:r>
+            </a:p>
+          </p:txBody>
+        </p:sp>
+      </p:grpSp>
+      <p:sp>
+        <p:nvSpPr>
+          <p:cNvPr id="3" name="TextBox 2">
+            <a:extLst>
+              <a:ext uri="{FF2B5EF4-FFF2-40B4-BE49-F238E27FC236}">
+                <a16:creationId xmlns:a16="http://schemas.microsoft.com/office/drawing/2014/main" id="{F004873E-19AC-EF0E-4509-F66C7EDC134C}"/>
+              </a:ext>
+            </a:extLst>
+          </p:cNvPr>
+          <p:cNvSpPr txBox="1"/>
+          <p:nvPr/>
+        </p:nvSpPr>
+        <p:spPr>
+          <a:xfrm>
+            <a:off x="4146211" y="4297678"/>
+            <a:ext cx="3889270" cy="1200329"/>
+          </a:xfrm>
+          <a:prstGeom prst="rect">
+            <a:avLst/>
+          </a:prstGeom>
+          <a:noFill/>
+        </p:spPr>
+        <p:txBody>
+          <a:bodyPr wrap="none" rtlCol="0">
+            <a:spAutoFit/>
+          </a:bodyPr>
+          <a:lstStyle/>
+          <a:p>
+            <a:r>
+              <a:rPr lang="en-US" sz="7200">
+                <a:solidFill>
+                  <a:schemeClr val="accent4">
+                    <a:lumMod val="75000"/>
+                  </a:schemeClr>
+                </a:solidFill>
+                <a:latin typeface="Perpetua Titling MT" panose="02020502060505020804" pitchFamily="18" charset="0"/>
+              </a:rPr>
+              <a:t>FlorAn</a:t>
+            </a:r>
+          </a:p>
+        </p:txBody>
+      </p:sp>
+      <p:sp>
+        <p:nvSpPr>
+          <p:cNvPr id="7" name="TextBox 6">
+            <a:extLst>
+              <a:ext uri="{FF2B5EF4-FFF2-40B4-BE49-F238E27FC236}">
+                <a16:creationId xmlns:a16="http://schemas.microsoft.com/office/drawing/2014/main" id="{2DA0177E-3D70-DB70-E990-66830F20EB7D}"/>
+              </a:ext>
+            </a:extLst>
+          </p:cNvPr>
+          <p:cNvSpPr txBox="1"/>
+          <p:nvPr/>
+        </p:nvSpPr>
+        <p:spPr>
+          <a:xfrm>
+            <a:off x="3477855" y="5914158"/>
+            <a:ext cx="5225982" cy="707886"/>
+          </a:xfrm>
+          <a:prstGeom prst="rect">
+            <a:avLst/>
+          </a:prstGeom>
+          <a:noFill/>
+        </p:spPr>
+        <p:txBody>
+          <a:bodyPr wrap="none" rtlCol="0">
+            <a:spAutoFit/>
+          </a:bodyPr>
+          <a:lstStyle/>
+          <a:p>
+            <a:r>
+              <a:rPr lang="en-US" sz="4000">
+                <a:solidFill>
+                  <a:schemeClr val="accent5"/>
+                </a:solidFill>
+                <a:latin typeface="Perpetua Titling MT" panose="02020502060505020804" pitchFamily="18" charset="0"/>
+              </a:rPr>
+              <a:t>Floristic Analysis</a:t>
+            </a:r>
+          </a:p>
+        </p:txBody>
+      </p:sp>
+    </p:spTree>
+    <p:extLst>
+      <p:ext uri="{BB962C8B-B14F-4D97-AF65-F5344CB8AC3E}">
+        <p14:creationId xmlns:p14="http://schemas.microsoft.com/office/powerpoint/2010/main" val="2001357204"/>
+      </p:ext>
+    </p:extLst>
+  </p:cSld>
+  <p:clrMapOvr>
+    <a:masterClrMapping/>
+  </p:clrMapOvr>
+</p:sld>
+</file>
+
+<file path=ppt/slides/slide24.xml><?xml version="1.0" encoding="utf-8"?>
+<p:sld xmlns:a="http://schemas.openxmlformats.org/drawingml/2006/main" xmlns:r="http://schemas.openxmlformats.org/officeDocument/2006/relationships" xmlns:p="http://schemas.openxmlformats.org/presentationml/2006/main">
+  <p:cSld>
+    <p:spTree>
+      <p:nvGrpSpPr>
+        <p:cNvPr id="1" name="">
+          <a:extLst>
+            <a:ext uri="{FF2B5EF4-FFF2-40B4-BE49-F238E27FC236}">
+              <a16:creationId xmlns:a16="http://schemas.microsoft.com/office/drawing/2014/main" id="{9B632D01-D12D-5CE5-ACA7-AE76F87C2156}"/>
+            </a:ext>
+          </a:extLst>
+        </p:cNvPr>
+        <p:cNvGrpSpPr/>
+        <p:nvPr/>
+      </p:nvGrpSpPr>
+      <p:grpSpPr>
+        <a:xfrm>
+          <a:off x="0" y="0"/>
+          <a:ext cx="0" cy="0"/>
+          <a:chOff x="0" y="0"/>
+          <a:chExt cx="0" cy="0"/>
+        </a:xfrm>
+      </p:grpSpPr>
+      <p:sp>
+        <p:nvSpPr>
+          <p:cNvPr id="3" name="TextBox 2">
+            <a:extLst>
+              <a:ext uri="{FF2B5EF4-FFF2-40B4-BE49-F238E27FC236}">
+                <a16:creationId xmlns:a16="http://schemas.microsoft.com/office/drawing/2014/main" id="{F585B933-806E-B39B-7A39-60F5419C457B}"/>
+              </a:ext>
+            </a:extLst>
+          </p:cNvPr>
+          <p:cNvSpPr txBox="1"/>
+          <p:nvPr/>
+        </p:nvSpPr>
+        <p:spPr>
+          <a:xfrm>
+            <a:off x="452413" y="634015"/>
+            <a:ext cx="11398928" cy="3785652"/>
+          </a:xfrm>
+          <a:prstGeom prst="rect">
+            <a:avLst/>
+          </a:prstGeom>
+          <a:noFill/>
+        </p:spPr>
+        <p:txBody>
+          <a:bodyPr wrap="square" rtlCol="0">
+            <a:spAutoFit/>
+          </a:bodyPr>
+          <a:lstStyle/>
+          <a:p>
+            <a:endParaRPr lang="en-US" sz="6000" b="1">
+              <a:latin typeface="Barlow Condensed ExtraLight" panose="00000306000000000000" pitchFamily="2" charset="0"/>
+            </a:endParaRPr>
+          </a:p>
+          <a:p>
+            <a:r>
+              <a:rPr lang="en-US" sz="6000" b="1">
+                <a:latin typeface="Barlow Condensed ExtraLight" panose="00000306000000000000" pitchFamily="2" charset="0"/>
+              </a:rPr>
+              <a:t>example:</a:t>
+            </a:r>
+          </a:p>
+          <a:p>
+            <a:endParaRPr lang="en-US" sz="6000" b="1">
+              <a:latin typeface="Barlow Condensed ExtraLight" panose="00000306000000000000" pitchFamily="2" charset="0"/>
+            </a:endParaRPr>
+          </a:p>
+          <a:p>
+            <a:r>
+              <a:rPr lang="en-US" sz="6000" b="1">
+                <a:solidFill>
+                  <a:schemeClr val="bg2">
+                    <a:lumMod val="75000"/>
+                  </a:schemeClr>
+                </a:solidFill>
+                <a:latin typeface="Barlow Condensed ExtraLight" panose="00000306000000000000" pitchFamily="2" charset="0"/>
+              </a:rPr>
+              <a:t>Use local floras studied in: </a:t>
+            </a:r>
+            <a:r>
+              <a:rPr lang="en-US" sz="6000" b="1">
+                <a:solidFill>
+                  <a:schemeClr val="accent5"/>
+                </a:solidFill>
+                <a:latin typeface="Barlow Condensed ExtraLight" panose="00000306000000000000" pitchFamily="2" charset="0"/>
+              </a:rPr>
+              <a:t>Egypt</a:t>
+            </a:r>
+          </a:p>
+        </p:txBody>
+      </p:sp>
+    </p:spTree>
+    <p:extLst>
+      <p:ext uri="{BB962C8B-B14F-4D97-AF65-F5344CB8AC3E}">
+        <p14:creationId xmlns:p14="http://schemas.microsoft.com/office/powerpoint/2010/main" val="3522417771"/>
+      </p:ext>
+    </p:extLst>
+  </p:cSld>
+  <p:clrMapOvr>
+    <a:masterClrMapping/>
+  </p:clrMapOvr>
+</p:sld>
+</file>
+
+<file path=ppt/slides/slide25.xml><?xml version="1.0" encoding="utf-8"?>
+<p:sld xmlns:a="http://schemas.openxmlformats.org/drawingml/2006/main" xmlns:r="http://schemas.openxmlformats.org/officeDocument/2006/relationships" xmlns:p="http://schemas.openxmlformats.org/presentationml/2006/main">
+  <p:cSld>
+    <p:spTree>
+      <p:nvGrpSpPr>
+        <p:cNvPr id="1" name="">
+          <a:extLst>
+            <a:ext uri="{FF2B5EF4-FFF2-40B4-BE49-F238E27FC236}">
+              <a16:creationId xmlns:a16="http://schemas.microsoft.com/office/drawing/2014/main" id="{454BEB89-E6A8-7C66-8D0D-432650967C5C}"/>
+            </a:ext>
+          </a:extLst>
+        </p:cNvPr>
+        <p:cNvGrpSpPr/>
+        <p:nvPr/>
+      </p:nvGrpSpPr>
+      <p:grpSpPr>
+        <a:xfrm>
+          <a:off x="0" y="0"/>
+          <a:ext cx="0" cy="0"/>
+          <a:chOff x="0" y="0"/>
+          <a:chExt cx="0" cy="0"/>
+        </a:xfrm>
+      </p:grpSpPr>
+      <p:grpSp>
+        <p:nvGrpSpPr>
+          <p:cNvPr id="2" name="Group 1">
+            <a:extLst>
+              <a:ext uri="{FF2B5EF4-FFF2-40B4-BE49-F238E27FC236}">
+                <a16:creationId xmlns:a16="http://schemas.microsoft.com/office/drawing/2014/main" id="{1381B3C3-CF3D-B6F6-3D41-E59EDCD320F5}"/>
+              </a:ext>
+            </a:extLst>
+          </p:cNvPr>
+          <p:cNvGrpSpPr/>
+          <p:nvPr/>
+        </p:nvGrpSpPr>
+        <p:grpSpPr>
+          <a:xfrm>
+            <a:off x="1492264" y="684300"/>
+            <a:ext cx="9197163" cy="3197227"/>
+            <a:chOff x="0" y="368960"/>
+            <a:chExt cx="10572223" cy="5038746"/>
+          </a:xfrm>
+        </p:grpSpPr>
+        <p:sp>
+          <p:nvSpPr>
+            <p:cNvPr id="6" name="Isosceles Triangle 5">
+              <a:extLst>
+                <a:ext uri="{FF2B5EF4-FFF2-40B4-BE49-F238E27FC236}">
+                  <a16:creationId xmlns:a16="http://schemas.microsoft.com/office/drawing/2014/main" id="{52056C83-ABB2-809A-1E48-74B96EF67EF3}"/>
+                </a:ext>
+              </a:extLst>
+            </p:cNvPr>
+            <p:cNvSpPr/>
+            <p:nvPr/>
+          </p:nvSpPr>
+          <p:spPr>
+            <a:xfrm>
+              <a:off x="0" y="939103"/>
+              <a:ext cx="10572223" cy="4468603"/>
+            </a:xfrm>
+            <a:custGeom>
+              <a:avLst/>
+              <a:gdLst>
+                <a:gd name="csX0" fmla="*/ 0 w 8324850"/>
+                <a:gd name="csY0" fmla="*/ 4282379 h 4282379"/>
+                <a:gd name="csX1" fmla="*/ 7010400 w 8324850"/>
+                <a:gd name="csY1" fmla="*/ 0 h 4282379"/>
+                <a:gd name="csX2" fmla="*/ 8324850 w 8324850"/>
+                <a:gd name="csY2" fmla="*/ 4282379 h 4282379"/>
+                <a:gd name="csX3" fmla="*/ 0 w 8324850"/>
+                <a:gd name="csY3" fmla="*/ 4282379 h 4282379"/>
+              </a:gdLst>
+              <a:ahLst/>
+              <a:cxnLst>
+                <a:cxn ang="0">
+                  <a:pos x="csX0" y="csY0"/>
+                </a:cxn>
+                <a:cxn ang="0">
+                  <a:pos x="csX1" y="csY1"/>
+                </a:cxn>
+                <a:cxn ang="0">
+                  <a:pos x="csX2" y="csY2"/>
+                </a:cxn>
+                <a:cxn ang="0">
+                  <a:pos x="csX3" y="csY3"/>
+                </a:cxn>
+              </a:cxnLst>
+              <a:rect l="l" t="t" r="r" b="b"/>
+              <a:pathLst>
+                <a:path w="8324850" h="4282379">
+                  <a:moveTo>
+                    <a:pt x="0" y="4282379"/>
+                  </a:moveTo>
+                  <a:lnTo>
+                    <a:pt x="7010400" y="0"/>
+                  </a:lnTo>
+                  <a:lnTo>
+                    <a:pt x="8324850" y="4282379"/>
+                  </a:lnTo>
+                  <a:lnTo>
+                    <a:pt x="0" y="4282379"/>
+                  </a:lnTo>
+                  <a:close/>
+                </a:path>
+              </a:pathLst>
+            </a:custGeom>
+            <a:solidFill>
+              <a:srgbClr val="FFFFB7"/>
+            </a:solidFill>
+            <a:ln>
+              <a:noFill/>
+            </a:ln>
+          </p:spPr>
+          <p:style>
+            <a:lnRef idx="2">
+              <a:schemeClr val="accent1">
+                <a:shade val="15000"/>
+              </a:schemeClr>
+            </a:lnRef>
+            <a:fillRef idx="1">
+              <a:schemeClr val="accent1"/>
+            </a:fillRef>
+            <a:effectRef idx="0">
+              <a:schemeClr val="accent1"/>
+            </a:effectRef>
+            <a:fontRef idx="minor">
+              <a:schemeClr val="lt1"/>
+            </a:fontRef>
+          </p:style>
+          <p:txBody>
+            <a:bodyPr rtlCol="0" anchor="ctr"/>
+            <a:lstStyle/>
+            <a:p>
+              <a:pPr algn="ctr"/>
+              <a:endParaRPr lang="en-US"/>
+            </a:p>
+          </p:txBody>
+        </p:sp>
+        <p:sp>
+          <p:nvSpPr>
+            <p:cNvPr id="5" name="TextBox 4">
+              <a:extLst>
+                <a:ext uri="{FF2B5EF4-FFF2-40B4-BE49-F238E27FC236}">
+                  <a16:creationId xmlns:a16="http://schemas.microsoft.com/office/drawing/2014/main" id="{EFF76388-683C-DC4A-384B-1ECE4B173FB5}"/>
+                </a:ext>
+              </a:extLst>
+            </p:cNvPr>
+            <p:cNvSpPr txBox="1"/>
+            <p:nvPr/>
+          </p:nvSpPr>
+          <p:spPr>
+            <a:xfrm>
+              <a:off x="779497" y="368960"/>
+              <a:ext cx="6287554" cy="4171410"/>
+            </a:xfrm>
+            <a:prstGeom prst="rect">
+              <a:avLst/>
+            </a:prstGeom>
+            <a:noFill/>
+          </p:spPr>
+          <p:txBody>
+            <a:bodyPr wrap="square" rtlCol="0">
+              <a:spAutoFit/>
+            </a:bodyPr>
+            <a:lstStyle/>
+            <a:p>
+              <a:pPr algn="l" rtl="0"/>
+              <a:r>
+                <a:rPr lang="en-US" sz="16600" i="1">
+                  <a:solidFill>
+                    <a:schemeClr val="tx1"/>
+                  </a:solidFill>
+                  <a:latin typeface="Rastanty Cortez" panose="020F0502020204030204" pitchFamily="2" charset="0"/>
+                  <a:ea typeface="Dotum" panose="020B0600000101010101" pitchFamily="34" charset="-127"/>
+                  <a:cs typeface="Biome Light" panose="020B0303030204020804" pitchFamily="34" charset="0"/>
+                </a:rPr>
+                <a:t>Al</a:t>
+              </a:r>
+              <a:r>
+                <a:rPr lang="en-US" sz="16600" i="1">
+                  <a:latin typeface="Rastanty Cortez" panose="020F0502020204030204" pitchFamily="2" charset="0"/>
+                  <a:ea typeface="Dotum" panose="020B0600000101010101" pitchFamily="34" charset="-127"/>
+                  <a:cs typeface="Biome Light" panose="020B0303030204020804" pitchFamily="34" charset="0"/>
+                </a:rPr>
+                <a:t>a</a:t>
+              </a:r>
+              <a:r>
+                <a:rPr lang="en-US" sz="16600" i="1">
+                  <a:solidFill>
+                    <a:srgbClr val="C00000"/>
+                  </a:solidFill>
+                  <a:latin typeface="Rastanty Cortez" panose="020F0502020204030204" pitchFamily="2" charset="0"/>
+                  <a:ea typeface="Dotum" panose="020B0600000101010101" pitchFamily="34" charset="-127"/>
+                  <a:cs typeface="Biome Light" panose="020B0303030204020804" pitchFamily="34" charset="0"/>
+                </a:rPr>
+                <a:t>m</a:t>
+              </a:r>
+              <a:r>
+                <a:rPr lang="en-US" sz="16600" i="1">
+                  <a:solidFill>
+                    <a:schemeClr val="tx1"/>
+                  </a:solidFill>
+                  <a:latin typeface="Rastanty Cortez" panose="020F0502020204030204" pitchFamily="2" charset="0"/>
+                  <a:ea typeface="Dotum" panose="020B0600000101010101" pitchFamily="34" charset="-127"/>
+                  <a:cs typeface="Biome Light" panose="020B0303030204020804" pitchFamily="34" charset="0"/>
+                </a:rPr>
+                <a:t>ut</a:t>
+              </a:r>
+            </a:p>
+          </p:txBody>
+        </p:sp>
+      </p:grpSp>
+      <p:sp>
+        <p:nvSpPr>
+          <p:cNvPr id="3" name="TextBox 2">
+            <a:extLst>
+              <a:ext uri="{FF2B5EF4-FFF2-40B4-BE49-F238E27FC236}">
+                <a16:creationId xmlns:a16="http://schemas.microsoft.com/office/drawing/2014/main" id="{11BE27C4-356C-78A8-1FD6-EAC8B837735D}"/>
+              </a:ext>
+            </a:extLst>
+          </p:cNvPr>
+          <p:cNvSpPr txBox="1"/>
+          <p:nvPr/>
+        </p:nvSpPr>
+        <p:spPr>
+          <a:xfrm>
+            <a:off x="1847504" y="4297678"/>
+            <a:ext cx="8486682" cy="1200329"/>
+          </a:xfrm>
+          <a:prstGeom prst="rect">
+            <a:avLst/>
+          </a:prstGeom>
+          <a:noFill/>
+        </p:spPr>
+        <p:txBody>
+          <a:bodyPr wrap="none" rtlCol="0">
+            <a:spAutoFit/>
+          </a:bodyPr>
+          <a:lstStyle/>
+          <a:p>
+            <a:r>
+              <a:rPr lang="en-US" sz="7200">
+                <a:solidFill>
+                  <a:schemeClr val="accent4">
+                    <a:lumMod val="75000"/>
+                  </a:schemeClr>
+                </a:solidFill>
+                <a:latin typeface="Perpetua Titling MT" panose="02020502060505020804" pitchFamily="18" charset="0"/>
+              </a:rPr>
+              <a:t>MultivarFlorAn</a:t>
+            </a:r>
+          </a:p>
+        </p:txBody>
+      </p:sp>
+      <p:sp>
+        <p:nvSpPr>
+          <p:cNvPr id="7" name="TextBox 6">
+            <a:extLst>
+              <a:ext uri="{FF2B5EF4-FFF2-40B4-BE49-F238E27FC236}">
+                <a16:creationId xmlns:a16="http://schemas.microsoft.com/office/drawing/2014/main" id="{8CFAD7CB-E815-D75F-F0C8-136EC910E5E8}"/>
+              </a:ext>
+            </a:extLst>
+          </p:cNvPr>
+          <p:cNvSpPr txBox="1"/>
+          <p:nvPr/>
+        </p:nvSpPr>
+        <p:spPr>
+          <a:xfrm>
+            <a:off x="2021557" y="5993671"/>
+            <a:ext cx="8138575" cy="646331"/>
+          </a:xfrm>
+          <a:prstGeom prst="rect">
+            <a:avLst/>
+          </a:prstGeom>
+          <a:noFill/>
+        </p:spPr>
+        <p:txBody>
+          <a:bodyPr wrap="none" rtlCol="0">
+            <a:spAutoFit/>
+          </a:bodyPr>
+          <a:lstStyle/>
+          <a:p>
+            <a:r>
+              <a:rPr lang="en-US" sz="3600">
+                <a:solidFill>
+                  <a:schemeClr val="accent5"/>
+                </a:solidFill>
+                <a:latin typeface="Perpetua Titling MT" panose="02020502060505020804" pitchFamily="18" charset="0"/>
+              </a:rPr>
+              <a:t>Multivariate Floristic Analysis</a:t>
+            </a:r>
+          </a:p>
+        </p:txBody>
+      </p:sp>
+    </p:spTree>
+    <p:extLst>
+      <p:ext uri="{BB962C8B-B14F-4D97-AF65-F5344CB8AC3E}">
+        <p14:creationId xmlns:p14="http://schemas.microsoft.com/office/powerpoint/2010/main" val="3141218047"/>
+      </p:ext>
+    </p:extLst>
+  </p:cSld>
+  <p:clrMapOvr>
+    <a:masterClrMapping/>
+  </p:clrMapOvr>
+</p:sld>
+</file>
+
+<file path=ppt/slides/slide26.xml><?xml version="1.0" encoding="utf-8"?>
+<p:sld xmlns:a="http://schemas.openxmlformats.org/drawingml/2006/main" xmlns:r="http://schemas.openxmlformats.org/officeDocument/2006/relationships" xmlns:p="http://schemas.openxmlformats.org/presentationml/2006/main">
+  <p:cSld>
+    <p:spTree>
+      <p:nvGrpSpPr>
+        <p:cNvPr id="1" name="">
+          <a:extLst>
+            <a:ext uri="{FF2B5EF4-FFF2-40B4-BE49-F238E27FC236}">
+              <a16:creationId xmlns:a16="http://schemas.microsoft.com/office/drawing/2014/main" id="{E31014F0-0D90-350E-8A80-C2C181FBE4F0}"/>
+            </a:ext>
+          </a:extLst>
+        </p:cNvPr>
+        <p:cNvGrpSpPr/>
+        <p:nvPr/>
+      </p:nvGrpSpPr>
+      <p:grpSpPr>
+        <a:xfrm>
+          <a:off x="0" y="0"/>
+          <a:ext cx="0" cy="0"/>
+          <a:chOff x="0" y="0"/>
+          <a:chExt cx="0" cy="0"/>
+        </a:xfrm>
+      </p:grpSpPr>
+      <p:sp>
+        <p:nvSpPr>
+          <p:cNvPr id="3" name="TextBox 2">
+            <a:extLst>
+              <a:ext uri="{FF2B5EF4-FFF2-40B4-BE49-F238E27FC236}">
+                <a16:creationId xmlns:a16="http://schemas.microsoft.com/office/drawing/2014/main" id="{E95D4890-57BD-329A-2802-85C2D1ED7C25}"/>
+              </a:ext>
+            </a:extLst>
+          </p:cNvPr>
+          <p:cNvSpPr txBox="1"/>
+          <p:nvPr/>
+        </p:nvSpPr>
+        <p:spPr>
+          <a:xfrm>
+            <a:off x="0" y="634015"/>
+            <a:ext cx="5118847" cy="5078313"/>
+          </a:xfrm>
+          <a:prstGeom prst="rect">
+            <a:avLst/>
+          </a:prstGeom>
+          <a:noFill/>
+        </p:spPr>
+        <p:txBody>
+          <a:bodyPr wrap="square" rtlCol="0">
+            <a:spAutoFit/>
+          </a:bodyPr>
+          <a:lstStyle/>
+          <a:p>
+            <a:endParaRPr lang="en-US" sz="5400" b="1">
+              <a:latin typeface="Barlow Condensed ExtraLight" panose="00000306000000000000" pitchFamily="2" charset="0"/>
+            </a:endParaRPr>
+          </a:p>
+          <a:p>
+            <a:r>
+              <a:rPr lang="en-US" sz="5400" b="1">
+                <a:latin typeface="Barlow Condensed ExtraLight" panose="00000306000000000000" pitchFamily="2" charset="0"/>
+              </a:rPr>
+              <a:t>example:</a:t>
+            </a:r>
+          </a:p>
+          <a:p>
+            <a:endParaRPr lang="en-US" sz="5400" b="1">
+              <a:latin typeface="Barlow Condensed ExtraLight" panose="00000306000000000000" pitchFamily="2" charset="0"/>
+            </a:endParaRPr>
+          </a:p>
+          <a:p>
+            <a:r>
+              <a:rPr lang="en-US" sz="5400" b="1">
+                <a:solidFill>
+                  <a:schemeClr val="bg2">
+                    <a:lumMod val="75000"/>
+                  </a:schemeClr>
+                </a:solidFill>
+                <a:latin typeface="Barlow Condensed ExtraLight" panose="00000306000000000000" pitchFamily="2" charset="0"/>
+              </a:rPr>
+              <a:t>Use local floras</a:t>
+            </a:r>
+          </a:p>
+          <a:p>
+            <a:r>
+              <a:rPr lang="en-US" sz="5400" b="1">
+                <a:solidFill>
+                  <a:schemeClr val="bg2">
+                    <a:lumMod val="75000"/>
+                  </a:schemeClr>
+                </a:solidFill>
+                <a:latin typeface="Barlow Condensed ExtraLight" panose="00000306000000000000" pitchFamily="2" charset="0"/>
+              </a:rPr>
+              <a:t> studied in:</a:t>
+            </a:r>
+          </a:p>
+          <a:p>
+            <a:r>
+              <a:rPr lang="en-US" sz="5400" b="1">
+                <a:solidFill>
+                  <a:schemeClr val="bg2">
+                    <a:lumMod val="75000"/>
+                  </a:schemeClr>
+                </a:solidFill>
+                <a:latin typeface="Barlow Condensed ExtraLight" panose="00000306000000000000" pitchFamily="2" charset="0"/>
+              </a:rPr>
+              <a:t> </a:t>
+            </a:r>
+            <a:r>
+              <a:rPr lang="en-US" sz="5400" b="1">
+                <a:solidFill>
+                  <a:schemeClr val="accent5"/>
+                </a:solidFill>
+                <a:latin typeface="Barlow Condensed ExtraLight" panose="00000306000000000000" pitchFamily="2" charset="0"/>
+              </a:rPr>
+              <a:t>Oman and Pakistan</a:t>
+            </a:r>
+          </a:p>
+        </p:txBody>
+      </p:sp>
+      <p:grpSp>
+        <p:nvGrpSpPr>
+          <p:cNvPr id="6" name="Group 5">
+            <a:extLst>
+              <a:ext uri="{FF2B5EF4-FFF2-40B4-BE49-F238E27FC236}">
+                <a16:creationId xmlns:a16="http://schemas.microsoft.com/office/drawing/2014/main" id="{A39A5956-6729-2D2F-1CBD-CE0ECA41ACE5}"/>
+              </a:ext>
+            </a:extLst>
+          </p:cNvPr>
+          <p:cNvGrpSpPr/>
+          <p:nvPr/>
+        </p:nvGrpSpPr>
+        <p:grpSpPr>
+          <a:xfrm>
+            <a:off x="4696063" y="634014"/>
+            <a:ext cx="7495937" cy="6223985"/>
+            <a:chOff x="4052046" y="634014"/>
+            <a:chExt cx="7495937" cy="6223985"/>
+          </a:xfrm>
+        </p:grpSpPr>
+        <p:pic>
+          <p:nvPicPr>
+            <p:cNvPr id="7" name="Picture 6">
+              <a:extLst>
+                <a:ext uri="{FF2B5EF4-FFF2-40B4-BE49-F238E27FC236}">
+                  <a16:creationId xmlns:a16="http://schemas.microsoft.com/office/drawing/2014/main" id="{45A0883F-0A8D-6A16-4F30-D3FC9E9BD34E}"/>
+                </a:ext>
+              </a:extLst>
+            </p:cNvPr>
+            <p:cNvPicPr>
+              <a:picLocks noChangeAspect="1"/>
+            </p:cNvPicPr>
+            <p:nvPr/>
+          </p:nvPicPr>
+          <p:blipFill>
+            <a:blip r:embed="rId2"/>
+            <a:srcRect l="31255" t="9245"/>
+            <a:stretch>
+              <a:fillRect/>
+            </a:stretch>
+          </p:blipFill>
+          <p:spPr>
+            <a:xfrm>
+              <a:off x="4052046" y="634014"/>
+              <a:ext cx="7495937" cy="6223985"/>
+            </a:xfrm>
+            <a:prstGeom prst="rect">
+              <a:avLst/>
+            </a:prstGeom>
+          </p:spPr>
+        </p:pic>
+        <p:sp>
+          <p:nvSpPr>
+            <p:cNvPr id="8" name="Oval 7">
+              <a:extLst>
+                <a:ext uri="{FF2B5EF4-FFF2-40B4-BE49-F238E27FC236}">
+                  <a16:creationId xmlns:a16="http://schemas.microsoft.com/office/drawing/2014/main" id="{67A188FB-175D-5E2F-3EF5-08D1FA8DA675}"/>
+                </a:ext>
+              </a:extLst>
+            </p:cNvPr>
+            <p:cNvSpPr/>
+            <p:nvPr/>
+          </p:nvSpPr>
+          <p:spPr>
+            <a:xfrm rot="2089281">
+              <a:off x="4352807" y="4155545"/>
+              <a:ext cx="933163" cy="1865203"/>
+            </a:xfrm>
+            <a:prstGeom prst="ellipse">
+              <a:avLst/>
+            </a:prstGeom>
+            <a:noFill/>
+            <a:ln w="38100">
+              <a:solidFill>
+                <a:srgbClr val="FF0000"/>
+              </a:solidFill>
+            </a:ln>
+          </p:spPr>
+          <p:style>
+            <a:lnRef idx="2">
+              <a:schemeClr val="accent1">
+                <a:shade val="15000"/>
+              </a:schemeClr>
+            </a:lnRef>
+            <a:fillRef idx="1">
+              <a:schemeClr val="accent1"/>
+            </a:fillRef>
+            <a:effectRef idx="0">
+              <a:schemeClr val="accent1"/>
+            </a:effectRef>
+            <a:fontRef idx="minor">
+              <a:schemeClr val="lt1"/>
+            </a:fontRef>
+          </p:style>
+          <p:txBody>
+            <a:bodyPr rtlCol="0" anchor="ctr"/>
+            <a:lstStyle/>
+            <a:p>
+              <a:pPr algn="ctr"/>
+              <a:endParaRPr lang="en-US"/>
+            </a:p>
+          </p:txBody>
+        </p:sp>
+        <p:sp>
+          <p:nvSpPr>
+            <p:cNvPr id="9" name="Oval 8">
+              <a:extLst>
+                <a:ext uri="{FF2B5EF4-FFF2-40B4-BE49-F238E27FC236}">
+                  <a16:creationId xmlns:a16="http://schemas.microsoft.com/office/drawing/2014/main" id="{F1B4DAE6-9A28-A1F7-6C4F-9DD11206D566}"/>
+                </a:ext>
+              </a:extLst>
+            </p:cNvPr>
+            <p:cNvSpPr/>
+            <p:nvPr/>
+          </p:nvSpPr>
+          <p:spPr>
+            <a:xfrm rot="2669135">
+              <a:off x="6992413" y="1488042"/>
+              <a:ext cx="1210235" cy="2532613"/>
+            </a:xfrm>
+            <a:prstGeom prst="ellipse">
+              <a:avLst/>
+            </a:prstGeom>
+            <a:noFill/>
+            <a:ln w="38100">
+              <a:solidFill>
+                <a:srgbClr val="FF0000"/>
+              </a:solidFill>
+            </a:ln>
+          </p:spPr>
+          <p:style>
+            <a:lnRef idx="2">
+              <a:schemeClr val="accent1">
+                <a:shade val="15000"/>
+              </a:schemeClr>
+            </a:lnRef>
+            <a:fillRef idx="1">
+              <a:schemeClr val="accent1"/>
+            </a:fillRef>
+            <a:effectRef idx="0">
+              <a:schemeClr val="accent1"/>
+            </a:effectRef>
+            <a:fontRef idx="minor">
+              <a:schemeClr val="lt1"/>
+            </a:fontRef>
+          </p:style>
+          <p:txBody>
+            <a:bodyPr rtlCol="0" anchor="ctr"/>
+            <a:lstStyle/>
+            <a:p>
+              <a:pPr algn="ctr"/>
+              <a:endParaRPr lang="en-US"/>
+            </a:p>
+          </p:txBody>
+        </p:sp>
+      </p:grpSp>
+    </p:spTree>
+    <p:extLst>
+      <p:ext uri="{BB962C8B-B14F-4D97-AF65-F5344CB8AC3E}">
+        <p14:creationId xmlns:p14="http://schemas.microsoft.com/office/powerpoint/2010/main" val="2938684782"/>
+      </p:ext>
+    </p:extLst>
+  </p:cSld>
+  <p:clrMapOvr>
+    <a:masterClrMapping/>
+  </p:clrMapOvr>
+</p:sld>
+</file>
+
 <file path=ppt/slides/slide3.xml><?xml version="1.0" encoding="utf-8"?>
 <p:sld xmlns:a="http://schemas.openxmlformats.org/drawingml/2006/main" xmlns:r="http://schemas.openxmlformats.org/officeDocument/2006/relationships" xmlns:p="http://schemas.openxmlformats.org/presentationml/2006/main">
   <p:cSld>

</xml_diff>